<commit_message>
Overview deck: four servers, P5 manifest replay, 0.2.0 getting started, tool reference and pilot status
Slide 6 shows the three bundled servers and the separately installed Radiant
server; slide 19 adds the manifest chain (YAML soc sections, make soc-manifest,
propel_replay_manifest, propel_compare_sbx_manifest); slide 22 describes the
0.2.0 installer and the project template; appendix A lists the current tool
names including soc_manifest and the lattice-cortex tools; appendix B marks P5
tools done and updates the open items.

Co-Authored-By: Claude Fable 5.1 <noreply@anthropic.com>
</commit_message>
<xml_diff>
--- a/docs/integrated_flow_overview.pptx
+++ b/docs/integrated_flow_overview.pptx
@@ -1225,7 +1225,7 @@
           <a:lstStyle/>
           <a:p>
             <a:r>
-              <a:t>When the intent needs a soft core, the Propel-generated SoC becomes an arch2code wrapper block: hasRtl, hasMdl and hasStub. arch2code scaffolds its RTL file and generates its ports; inside, outside the generated regions, the Propel top is instantiated. The stub is the bus-master transactor that drives the custom logic through the window before any RTL exists. The window is one pair of constants declared once in the YAML and once as the single Propel address segment, so arch2code, Propel and the firmware agree on the one address fact they share.</a:t>
+              <a:t>When the intent needs a soft core, the Propel-generated SoC becomes an arch2code wrapper block: hasRtl, hasMdl and hasStub. arch2code scaffolds its RTL file and generates its ports; inside, outside the generated regions, the Propel top is instantiated. The stub is the bus-master transactor that drives the custom logic through the window before any RTL exists. The window is one pair of constants declared once in the YAML and once as the single Propel address segment. Since phase P5 the SoC itself is described in the same YAML (socProjects, socInstances, socNets, socAddresses and the other soc sections): make soc-manifest writes a manifest from it, lattice-cortex replays the manifest into a Propel session with propel_replay_manifest, as a plan or for real, and propel_compare_sbx_manifest reports where an existing SoC file deviates from it. The agent no longer builds the SoC by hand; it checks a replay.</a:t>
             </a:r>
           </a:p>
         </p:txBody>
@@ -1505,7 +1505,7 @@
           <a:lstStyle/>
           <a:p>
             <a:r>
-              <a:t>Install the bundle: one archive, no administrator rights, the installer registers arch2code and the knowledge base with Claude Code and Claude Desktop, authoring tools on, and offers the reviewed skills. Open a project folder, or an existing arch2code, Propel or captured design, and tell Claude what you want to build; the design-from-intent skill asks the intake questions. Contacts and documents are on the slide; the bundle ships a project template (bin/new-project) with the record layout.</a:t>
+              <a:t>Install the bundle: one archive, no administrator rights, the installer registers arch2code, the knowledge base and lattice-cortex with Claude Code and Claude Desktop, authoring tools on; the reviewed skills are served by the knowledge-base server and deployed per project by make agents-setup. The Radiant server comes from its own installer. Open a project folder, or an existing arch2code, Propel or captured design, and tell Claude what you want to build; the design-from-intent skill asks the intake questions. Contacts and documents are on the slide; the bundle ships a project template (bin/new-project) with the record layout.</a:t>
             </a:r>
           </a:p>
         </p:txBody>
@@ -1575,7 +1575,7 @@
           <a:lstStyle/>
           <a:p>
             <a:r>
-              <a:t>Reference slide for the engineers who want to see the tool names. Twenty-four read-only knowledge-base tools, the authoring tools in a personal session, and the arch2code server tools.</a:t>
+              <a:t>Reference slide for the engineers who want to see the tool names. The read-only knowledge-base tools, the authoring tools of a personal session, the arch2code server tools with the P5 manifest generator, and the lattice-cortex tools that the flow uses most, among them the two manifest tools of release 0.2.0.</a:t>
             </a:r>
           </a:p>
         </p:txBody>
@@ -1645,7 +1645,7 @@
           <a:lstStyle/>
           <a:p>
             <a:r>
-              <a:t>Where the programme stands today. P0 to P4 are implemented on the toolchain side; the pilot design is drafted to Gate 1 and waits for the review. P5 removes the agent from the SoC replay loop; P6 generalises to a design without a SoC on a second family.</a:t>
+              <a:t>Where the programme stands today. P0 to P5 are implemented on the toolchain side and shipped in lattice-prompt 0.2.0: the manifest generator is merged in cortex-a2c, the replay and comparison tools are on the cortex-mcp flow_integration branch, which the bundle pins until the branch merges. The pilot design is drafted to Gate 1 and waits for the review; a live replay against Propel runs after Gate 2. P6 generalises to a design without a SoC on a second family.</a:t>
             </a:r>
           </a:p>
         </p:txBody>
@@ -1925,7 +1925,7 @@
           <a:lstStyle/>
           <a:p>
             <a:r>
-              <a:t>The agent in Claude Code talks to five MCP servers registered side by side. arch2code owns generation and simulation of the project. cortex-kb owns evidence: what exists, what was verified, where a value comes from. lattice-cortex owns the Propel SoC session and the firmware. The Radiant bundle owns the build, timing closure, programming and Reveal debug. When two servers know the same fact, the precedence rule in the project's AGENTS.md says which one wins and the disagreement is recorded.</a:t>
+              <a:t>The agent in Claude Code talks to four MCP servers registered side by side. Three come out of the lattice-prompt bundle and are registered by its installer: arch2code owns generation and simulation of the project; cortex-kb owns evidence, what exists, what was verified, where a value comes from; lattice-cortex owns the Propel SoC session, the IP facts and the firmware, and since release 0.2.0 the replay of an arch2code SoC manifest. The Radiant server ships with its own installer and owns the build, timing closure, programming and Reveal debug. When two servers know the same fact, the precedence rule in the project's AGENTS.md says which one wins and the disagreement is recorded.</a:t>
             </a:r>
           </a:p>
         </p:txBody>
@@ -17993,14 +17993,524 @@
       </p:sp>
       <p:sp>
         <p:nvSpPr>
-          <p:cNvPr id="22" name="TextBox 21"/>
-          <p:cNvSpPr txBox="1"/>
-          <p:nvPr/>
-        </p:nvSpPr>
-        <p:spPr>
-          <a:xfrm>
-            <a:off x="731520" y="5715000"/>
-            <a:ext cx="10881360" cy="548640"/>
+          <p:cNvPr id="22" name="pill"/>
+          <p:cNvSpPr/>
+          <p:nvPr/>
+        </p:nvSpPr>
+        <p:spPr>
+          <a:xfrm>
+            <a:off x="731520" y="5669280"/>
+            <a:ext cx="1486814" cy="310896"/>
+          </a:xfrm>
+          <a:prstGeom prst="roundRect">
+            <a:avLst>
+              <a:gd name="adj" fmla="val 50000"/>
+            </a:avLst>
+          </a:prstGeom>
+          <a:solidFill>
+            <a:srgbClr val="1C7293"/>
+          </a:solidFill>
+          <a:ln>
+            <a:noFill/>
+          </a:ln>
+          <a:effectLst/>
+        </p:spPr>
+        <p:style>
+          <a:lnRef idx="1">
+            <a:schemeClr val="accent1"/>
+          </a:lnRef>
+          <a:fillRef idx="3">
+            <a:schemeClr val="accent1"/>
+          </a:fillRef>
+          <a:effectRef idx="2">
+            <a:schemeClr val="accent1"/>
+          </a:effectRef>
+          <a:fontRef idx="minor">
+            <a:schemeClr val="lt1"/>
+          </a:fontRef>
+        </p:style>
+        <p:txBody>
+          <a:bodyPr rtlCol="0" anchor="ctr" lIns="0" rIns="0" tIns="0" bIns="0" wrap="square"/>
+          <a:lstStyle/>
+          <a:p>
+            <a:pPr algn="ctr"/>
+            <a:r>
+              <a:rPr sz="950" b="1" i="0">
+                <a:solidFill>
+                  <a:srgbClr val="FFFFFF"/>
+                </a:solidFill>
+                <a:latin typeface="Calibri"/>
+              </a:rPr>
+              <a:t>YAML soc sections</a:t>
+            </a:r>
+          </a:p>
+        </p:txBody>
+      </p:sp>
+      <p:cxnSp>
+        <p:nvCxnSpPr>
+          <p:cNvPr id="23" name="Connector 22"/>
+          <p:cNvCxnSpPr/>
+          <p:nvPr/>
+        </p:nvCxnSpPr>
+        <p:spPr>
+          <a:xfrm>
+            <a:off x="2245766" y="5824728"/>
+            <a:ext cx="201168" cy="0"/>
+          </a:xfrm>
+          <a:prstGeom prst="line">
+            <a:avLst/>
+          </a:prstGeom>
+          <a:ln w="15875">
+            <a:solidFill>
+              <a:srgbClr val="6C8EA4"/>
+            </a:solidFill>
+            <a:tailEnd type="triangle" w="med" len="med"/>
+          </a:ln>
+        </p:spPr>
+        <p:style>
+          <a:lnRef idx="2">
+            <a:schemeClr val="accent1"/>
+          </a:lnRef>
+          <a:fillRef idx="0">
+            <a:schemeClr val="accent1"/>
+          </a:fillRef>
+          <a:effectRef idx="1">
+            <a:schemeClr val="accent1"/>
+          </a:effectRef>
+          <a:fontRef idx="minor">
+            <a:schemeClr val="tx1"/>
+          </a:fontRef>
+        </p:style>
+      </p:cxnSp>
+      <p:sp>
+        <p:nvSpPr>
+          <p:cNvPr id="24" name="pill"/>
+          <p:cNvSpPr/>
+          <p:nvPr/>
+        </p:nvSpPr>
+        <p:spPr>
+          <a:xfrm>
+            <a:off x="2474366" y="5669280"/>
+            <a:ext cx="1486814" cy="310896"/>
+          </a:xfrm>
+          <a:prstGeom prst="roundRect">
+            <a:avLst>
+              <a:gd name="adj" fmla="val 50000"/>
+            </a:avLst>
+          </a:prstGeom>
+          <a:solidFill>
+            <a:srgbClr val="1C7293"/>
+          </a:solidFill>
+          <a:ln>
+            <a:noFill/>
+          </a:ln>
+          <a:effectLst/>
+        </p:spPr>
+        <p:style>
+          <a:lnRef idx="1">
+            <a:schemeClr val="accent1"/>
+          </a:lnRef>
+          <a:fillRef idx="3">
+            <a:schemeClr val="accent1"/>
+          </a:fillRef>
+          <a:effectRef idx="2">
+            <a:schemeClr val="accent1"/>
+          </a:effectRef>
+          <a:fontRef idx="minor">
+            <a:schemeClr val="lt1"/>
+          </a:fontRef>
+        </p:style>
+        <p:txBody>
+          <a:bodyPr rtlCol="0" anchor="ctr" lIns="0" rIns="0" tIns="0" bIns="0" wrap="square"/>
+          <a:lstStyle/>
+          <a:p>
+            <a:pPr algn="ctr"/>
+            <a:r>
+              <a:rPr sz="950" b="1" i="0">
+                <a:solidFill>
+                  <a:srgbClr val="FFFFFF"/>
+                </a:solidFill>
+                <a:latin typeface="Calibri"/>
+              </a:rPr>
+              <a:t>make soc-manifest</a:t>
+            </a:r>
+          </a:p>
+        </p:txBody>
+      </p:sp>
+      <p:cxnSp>
+        <p:nvCxnSpPr>
+          <p:cNvPr id="25" name="Connector 24"/>
+          <p:cNvCxnSpPr/>
+          <p:nvPr/>
+        </p:nvCxnSpPr>
+        <p:spPr>
+          <a:xfrm>
+            <a:off x="3988612" y="5824728"/>
+            <a:ext cx="201168" cy="0"/>
+          </a:xfrm>
+          <a:prstGeom prst="line">
+            <a:avLst/>
+          </a:prstGeom>
+          <a:ln w="15875">
+            <a:solidFill>
+              <a:srgbClr val="6C8EA4"/>
+            </a:solidFill>
+            <a:tailEnd type="triangle" w="med" len="med"/>
+          </a:ln>
+        </p:spPr>
+        <p:style>
+          <a:lnRef idx="2">
+            <a:schemeClr val="accent1"/>
+          </a:lnRef>
+          <a:fillRef idx="0">
+            <a:schemeClr val="accent1"/>
+          </a:fillRef>
+          <a:effectRef idx="1">
+            <a:schemeClr val="accent1"/>
+          </a:effectRef>
+          <a:fontRef idx="minor">
+            <a:schemeClr val="tx1"/>
+          </a:fontRef>
+        </p:style>
+      </p:cxnSp>
+      <p:sp>
+        <p:nvSpPr>
+          <p:cNvPr id="26" name="pill"/>
+          <p:cNvSpPr/>
+          <p:nvPr/>
+        </p:nvSpPr>
+        <p:spPr>
+          <a:xfrm>
+            <a:off x="4217212" y="5669280"/>
+            <a:ext cx="1201521" cy="310896"/>
+          </a:xfrm>
+          <a:prstGeom prst="roundRect">
+            <a:avLst>
+              <a:gd name="adj" fmla="val 50000"/>
+            </a:avLst>
+          </a:prstGeom>
+          <a:solidFill>
+            <a:srgbClr val="0F2A3F"/>
+          </a:solidFill>
+          <a:ln>
+            <a:noFill/>
+          </a:ln>
+          <a:effectLst/>
+        </p:spPr>
+        <p:style>
+          <a:lnRef idx="1">
+            <a:schemeClr val="accent1"/>
+          </a:lnRef>
+          <a:fillRef idx="3">
+            <a:schemeClr val="accent1"/>
+          </a:fillRef>
+          <a:effectRef idx="2">
+            <a:schemeClr val="accent1"/>
+          </a:effectRef>
+          <a:fontRef idx="minor">
+            <a:schemeClr val="lt1"/>
+          </a:fontRef>
+        </p:style>
+        <p:txBody>
+          <a:bodyPr rtlCol="0" anchor="ctr" lIns="0" rIns="0" tIns="0" bIns="0" wrap="square"/>
+          <a:lstStyle/>
+          <a:p>
+            <a:pPr algn="ctr"/>
+            <a:r>
+              <a:rPr sz="950" b="1" i="0">
+                <a:solidFill>
+                  <a:srgbClr val="FFFFFF"/>
+                </a:solidFill>
+                <a:latin typeface="Calibri"/>
+              </a:rPr>
+              <a:t>manifest.json</a:t>
+            </a:r>
+          </a:p>
+        </p:txBody>
+      </p:sp>
+      <p:cxnSp>
+        <p:nvCxnSpPr>
+          <p:cNvPr id="27" name="Connector 26"/>
+          <p:cNvCxnSpPr/>
+          <p:nvPr/>
+        </p:nvCxnSpPr>
+        <p:spPr>
+          <a:xfrm>
+            <a:off x="5446166" y="5824728"/>
+            <a:ext cx="201168" cy="0"/>
+          </a:xfrm>
+          <a:prstGeom prst="line">
+            <a:avLst/>
+          </a:prstGeom>
+          <a:ln w="15875">
+            <a:solidFill>
+              <a:srgbClr val="6C8EA4"/>
+            </a:solidFill>
+            <a:tailEnd type="triangle" w="med" len="med"/>
+          </a:ln>
+        </p:spPr>
+        <p:style>
+          <a:lnRef idx="2">
+            <a:schemeClr val="accent1"/>
+          </a:lnRef>
+          <a:fillRef idx="0">
+            <a:schemeClr val="accent1"/>
+          </a:fillRef>
+          <a:effectRef idx="1">
+            <a:schemeClr val="accent1"/>
+          </a:effectRef>
+          <a:fontRef idx="minor">
+            <a:schemeClr val="tx1"/>
+          </a:fontRef>
+        </p:style>
+      </p:cxnSp>
+      <p:sp>
+        <p:nvSpPr>
+          <p:cNvPr id="28" name="pill"/>
+          <p:cNvSpPr/>
+          <p:nvPr/>
+        </p:nvSpPr>
+        <p:spPr>
+          <a:xfrm>
+            <a:off x="5674766" y="5669280"/>
+            <a:ext cx="1843430" cy="310896"/>
+          </a:xfrm>
+          <a:prstGeom prst="roundRect">
+            <a:avLst>
+              <a:gd name="adj" fmla="val 50000"/>
+            </a:avLst>
+          </a:prstGeom>
+          <a:solidFill>
+            <a:srgbClr val="02C39A"/>
+          </a:solidFill>
+          <a:ln>
+            <a:noFill/>
+          </a:ln>
+          <a:effectLst/>
+        </p:spPr>
+        <p:style>
+          <a:lnRef idx="1">
+            <a:schemeClr val="accent1"/>
+          </a:lnRef>
+          <a:fillRef idx="3">
+            <a:schemeClr val="accent1"/>
+          </a:fillRef>
+          <a:effectRef idx="2">
+            <a:schemeClr val="accent1"/>
+          </a:effectRef>
+          <a:fontRef idx="minor">
+            <a:schemeClr val="lt1"/>
+          </a:fontRef>
+        </p:style>
+        <p:txBody>
+          <a:bodyPr rtlCol="0" anchor="ctr" lIns="0" rIns="0" tIns="0" bIns="0" wrap="square"/>
+          <a:lstStyle/>
+          <a:p>
+            <a:pPr algn="ctr"/>
+            <a:r>
+              <a:rPr sz="950" b="1" i="0">
+                <a:solidFill>
+                  <a:srgbClr val="FFFFFF"/>
+                </a:solidFill>
+                <a:latin typeface="Calibri"/>
+              </a:rPr>
+              <a:t>propel_replay_manifest</a:t>
+            </a:r>
+          </a:p>
+        </p:txBody>
+      </p:sp>
+      <p:cxnSp>
+        <p:nvCxnSpPr>
+          <p:cNvPr id="29" name="Connector 28"/>
+          <p:cNvCxnSpPr/>
+          <p:nvPr/>
+        </p:nvCxnSpPr>
+        <p:spPr>
+          <a:xfrm>
+            <a:off x="7545628" y="5824728"/>
+            <a:ext cx="201168" cy="0"/>
+          </a:xfrm>
+          <a:prstGeom prst="line">
+            <a:avLst/>
+          </a:prstGeom>
+          <a:ln w="15875">
+            <a:solidFill>
+              <a:srgbClr val="6C8EA4"/>
+            </a:solidFill>
+            <a:tailEnd type="triangle" w="med" len="med"/>
+          </a:ln>
+        </p:spPr>
+        <p:style>
+          <a:lnRef idx="2">
+            <a:schemeClr val="accent1"/>
+          </a:lnRef>
+          <a:fillRef idx="0">
+            <a:schemeClr val="accent1"/>
+          </a:fillRef>
+          <a:effectRef idx="1">
+            <a:schemeClr val="accent1"/>
+          </a:effectRef>
+          <a:fontRef idx="minor">
+            <a:schemeClr val="tx1"/>
+          </a:fontRef>
+        </p:style>
+      </p:cxnSp>
+      <p:sp>
+        <p:nvSpPr>
+          <p:cNvPr id="30" name="pill"/>
+          <p:cNvSpPr/>
+          <p:nvPr/>
+        </p:nvSpPr>
+        <p:spPr>
+          <a:xfrm>
+            <a:off x="7774228" y="5669280"/>
+            <a:ext cx="1272844" cy="310896"/>
+          </a:xfrm>
+          <a:prstGeom prst="roundRect">
+            <a:avLst>
+              <a:gd name="adj" fmla="val 50000"/>
+            </a:avLst>
+          </a:prstGeom>
+          <a:solidFill>
+            <a:srgbClr val="02C39A"/>
+          </a:solidFill>
+          <a:ln>
+            <a:noFill/>
+          </a:ln>
+          <a:effectLst/>
+        </p:spPr>
+        <p:style>
+          <a:lnRef idx="1">
+            <a:schemeClr val="accent1"/>
+          </a:lnRef>
+          <a:fillRef idx="3">
+            <a:schemeClr val="accent1"/>
+          </a:fillRef>
+          <a:effectRef idx="2">
+            <a:schemeClr val="accent1"/>
+          </a:effectRef>
+          <a:fontRef idx="minor">
+            <a:schemeClr val="lt1"/>
+          </a:fontRef>
+        </p:style>
+        <p:txBody>
+          <a:bodyPr rtlCol="0" anchor="ctr" lIns="0" rIns="0" tIns="0" bIns="0" wrap="square"/>
+          <a:lstStyle/>
+          <a:p>
+            <a:pPr algn="ctr"/>
+            <a:r>
+              <a:rPr sz="950" b="1" i="0">
+                <a:solidFill>
+                  <a:srgbClr val="FFFFFF"/>
+                </a:solidFill>
+                <a:latin typeface="Calibri"/>
+              </a:rPr>
+              <a:t>Propel session</a:t>
+            </a:r>
+          </a:p>
+        </p:txBody>
+      </p:sp>
+      <p:cxnSp>
+        <p:nvCxnSpPr>
+          <p:cNvPr id="31" name="Connector 30"/>
+          <p:cNvCxnSpPr/>
+          <p:nvPr/>
+        </p:nvCxnSpPr>
+        <p:spPr>
+          <a:xfrm>
+            <a:off x="9074505" y="5824728"/>
+            <a:ext cx="201168" cy="0"/>
+          </a:xfrm>
+          <a:prstGeom prst="line">
+            <a:avLst/>
+          </a:prstGeom>
+          <a:ln w="15875">
+            <a:solidFill>
+              <a:srgbClr val="6C8EA4"/>
+            </a:solidFill>
+            <a:tailEnd type="triangle" w="med" len="med"/>
+          </a:ln>
+        </p:spPr>
+        <p:style>
+          <a:lnRef idx="2">
+            <a:schemeClr val="accent1"/>
+          </a:lnRef>
+          <a:fillRef idx="0">
+            <a:schemeClr val="accent1"/>
+          </a:fillRef>
+          <a:effectRef idx="1">
+            <a:schemeClr val="accent1"/>
+          </a:effectRef>
+          <a:fontRef idx="minor">
+            <a:schemeClr val="tx1"/>
+          </a:fontRef>
+        </p:style>
+      </p:cxnSp>
+      <p:sp>
+        <p:nvSpPr>
+          <p:cNvPr id="32" name="pill"/>
+          <p:cNvSpPr/>
+          <p:nvPr/>
+        </p:nvSpPr>
+        <p:spPr>
+          <a:xfrm>
+            <a:off x="9303105" y="5669280"/>
+            <a:ext cx="2200046" cy="310896"/>
+          </a:xfrm>
+          <a:prstGeom prst="roundRect">
+            <a:avLst>
+              <a:gd name="adj" fmla="val 50000"/>
+            </a:avLst>
+          </a:prstGeom>
+          <a:solidFill>
+            <a:srgbClr val="E0A458"/>
+          </a:solidFill>
+          <a:ln>
+            <a:noFill/>
+          </a:ln>
+          <a:effectLst/>
+        </p:spPr>
+        <p:style>
+          <a:lnRef idx="1">
+            <a:schemeClr val="accent1"/>
+          </a:lnRef>
+          <a:fillRef idx="3">
+            <a:schemeClr val="accent1"/>
+          </a:fillRef>
+          <a:effectRef idx="2">
+            <a:schemeClr val="accent1"/>
+          </a:effectRef>
+          <a:fontRef idx="minor">
+            <a:schemeClr val="lt1"/>
+          </a:fontRef>
+        </p:style>
+        <p:txBody>
+          <a:bodyPr rtlCol="0" anchor="ctr" lIns="0" rIns="0" tIns="0" bIns="0" wrap="square"/>
+          <a:lstStyle/>
+          <a:p>
+            <a:pPr algn="ctr"/>
+            <a:r>
+              <a:rPr sz="950" b="1" i="0">
+                <a:solidFill>
+                  <a:srgbClr val="FFFFFF"/>
+                </a:solidFill>
+                <a:latin typeface="Calibri"/>
+              </a:rPr>
+              <a:t>propel_compare_sbx_manifest</a:t>
+            </a:r>
+          </a:p>
+        </p:txBody>
+      </p:sp>
+      <p:sp>
+        <p:nvSpPr>
+          <p:cNvPr id="33" name="TextBox 32"/>
+          <p:cNvSpPr txBox="1"/>
+          <p:nvPr/>
+        </p:nvSpPr>
+        <p:spPr>
+          <a:xfrm>
+            <a:off x="731520" y="6035040"/>
+            <a:ext cx="10881360" cy="411480"/>
           </a:xfrm>
           <a:prstGeom prst="rect">
             <a:avLst/>
@@ -18015,13 +18525,13 @@
           <a:p>
             <a:pPr algn="l"/>
             <a:r>
-              <a:rPr sz="1200" b="0" i="1">
+              <a:rPr sz="1050" b="0" i="1">
                 <a:solidFill>
                   <a:srgbClr val="6C8EA4"/>
                 </a:solidFill>
                 <a:latin typeface="Calibri"/>
               </a:rPr>
-              <a:t>The same window base and size reach the firmware headers, the Propel address segment and the SoC table; equivalence checks compare the Propel session with the table before the build.</a:t>
+              <a:t>P5: the SoC is declared in the YAML, the manifest is generated, lattice-cortex replays it into Propel and compares an existing .sbx against it; the window base and size reach the firmware headers, the Propel address segment and the manifest from the same declaration.</a:t>
             </a:r>
           </a:p>
         </p:txBody>
@@ -21977,7 +22487,7 @@
                 </a:solidFill>
                 <a:latin typeface="Calibri"/>
               </a:rPr>
-              <a:t>Unzip lattice-prompt-&lt;version&gt;-win64.zip or the Linux tarball; run install.cmd or install.sh. Choose the skills to install. Native simulation needs the toolchain described in the README.</a:t>
+              <a:t>Unzip lattice-prompt-0.2.0-win64.zip or the Linux tarball; run install.cmd or install.sh: arch2code, cortex-kb and lattice-cortex are registered. Install the Radiant server from its own package. Native simulation needs the toolchain described in the README.</a:t>
             </a:r>
           </a:p>
         </p:txBody>
@@ -22150,7 +22660,7 @@
                 </a:solidFill>
                 <a:latin typeface="Calibri"/>
               </a:rPr>
-              <a:t>A new folder, or an existing arch2code project, a captured design, or a Propel SoC. Say what it must do; the intake questionnaire covers the rest.</a:t>
+              <a:t>bin/new-project creates the project; make agents-setup deploys the rules and the knowledge-base skills. Say what it must do; the intake questionnaire covers the rest.</a:t>
             </a:r>
           </a:p>
         </p:txBody>
@@ -22459,7 +22969,7 @@
                 </a:solidFill>
                 <a:latin typeface="Calibri"/>
               </a:rPr>
-              <a:t>Repositories: cortex-a2c (arch2code and the skills), cortex-kb (the knowledge base), lattice-prompt (the release bundle)</a:t>
+              <a:t>Repositories: cortex-a2c (arch2code and the skills), cortex-kb (the knowledge base), cortex-mcp (lattice-cortex), cortex-bridge (the Radiant server), lattice-prompt (the release bundle, v0.2.0)</a:t>
             </a:r>
           </a:p>
           <a:p>
@@ -22621,8 +23131,8 @@
           <p:nvPr/>
         </p:nvGraphicFramePr>
         <p:xfrm>
-          <a:off x="548640" y="1325880"/>
-          <a:ext cx="11064240" cy="3291840"/>
+          <a:off x="548640" y="1234440"/>
+          <a:ext cx="11064240" cy="4023360"/>
         </p:xfrm>
         <a:graphic>
           <a:graphicData uri="http://schemas.openxmlformats.org/drawingml/2006/table">
@@ -22641,7 +23151,7 @@
                     <a:lstStyle/>
                     <a:p>
                       <a:r>
-                        <a:rPr sz="1100" b="1">
+                        <a:rPr sz="1050" b="1">
                           <a:solidFill>
                             <a:srgbClr val="FFFFFF"/>
                           </a:solidFill>
@@ -22663,7 +23173,7 @@
                     <a:lstStyle/>
                     <a:p>
                       <a:r>
-                        <a:rPr sz="1100" b="1">
+                        <a:rPr sz="1050" b="1">
                           <a:solidFill>
                             <a:srgbClr val="FFFFFF"/>
                           </a:solidFill>
@@ -22687,7 +23197,7 @@
                     <a:lstStyle/>
                     <a:p>
                       <a:r>
-                        <a:rPr sz="1100" b="1">
+                        <a:rPr sz="1050" b="1">
                           <a:solidFill>
                             <a:srgbClr val="1B2430"/>
                           </a:solidFill>
@@ -22709,13 +23219,13 @@
                     <a:lstStyle/>
                     <a:p>
                       <a:r>
-                        <a:rPr sz="1100" b="0">
+                        <a:rPr sz="1050" b="0">
                           <a:solidFill>
                             <a:srgbClr val="1B2430"/>
                           </a:solidFill>
                           <a:latin typeface="Calibri"/>
                         </a:rPr>
-                        <a:t>kb_status, kb_find_designs, kb_find_modules, kb_find_patterns, kb_find_ips, kb_find_skills, kb_get_entry, kb_get_module, kb_get_hierarchy, kb_get_dependencies, kb_find_instantiations, kb_list_files, kb_read_file, kb_get_flow, kb_get_constraints, kb_get_registers, kb_get_versions, kb_get_skill, kb_get_ip, kb_check_antipatterns, kb_get_template, kb_device_notes and the board tools</a:t>
+                        <a:t>kb_status, kb_find_designs, kb_find_modules, kb_find_patterns, kb_find_ips, kb_find_skills, kb_find_boards, kb_get_entry, kb_get_module, kb_get_hierarchy, kb_get_dependencies, kb_find_instantiations, kb_list_files, kb_read_file, kb_get_flow, kb_get_constraints, kb_get_registers, kb_get_versions, kb_get_skill, kb_get_ip, kb_get_board, kb_check_antipatterns, kb_get_template, kb_device_notes; every reviewed skill as a prompt</a:t>
                       </a:r>
                     </a:p>
                   </a:txBody>
@@ -22733,7 +23243,7 @@
                     <a:lstStyle/>
                     <a:p>
                       <a:r>
-                        <a:rPr sz="1100" b="1">
+                        <a:rPr sz="1050" b="1">
                           <a:solidFill>
                             <a:srgbClr val="1B2430"/>
                           </a:solidFill>
@@ -22755,13 +23265,13 @@
                     <a:lstStyle/>
                     <a:p>
                       <a:r>
-                        <a:rPr sz="1100" b="0">
+                        <a:rPr sz="1050" b="0">
                           <a:solidFill>
                             <a:srgbClr val="1B2430"/>
                           </a:solidFill>
                           <a:latin typeface="Calibri"/>
                         </a:rPr>
-                        <a:t>kb_author_inspect, kb_author_start, kb_author_status, kb_author_write_section, kb_author_write_skill, kb_author_add_skill, kb_author_validate, kb_author_export, kb_author_submit, kb_author_package, kb_author_import_package and the workspace helpers</a:t>
+                        <a:t>kb_author_inspect, kb_author_start, kb_author_get, kb_author_set_fields, kb_author_write_section, kb_author_write_skill, kb_author_add_skill, kb_author_propose_pattern, kb_author_validate, kb_author_export, kb_author_submit, kb_author_package, kb_author_import_package, kb_author_list, kb_author_discard</a:t>
                       </a:r>
                     </a:p>
                   </a:txBody>
@@ -22779,7 +23289,7 @@
                     <a:lstStyle/>
                     <a:p>
                       <a:r>
-                        <a:rPr sz="1100" b="1">
+                        <a:rPr sz="1050" b="1">
                           <a:solidFill>
                             <a:srgbClr val="1B2430"/>
                           </a:solidFill>
@@ -22801,13 +23311,13 @@
                     <a:lstStyle/>
                     <a:p>
                       <a:r>
-                        <a:rPr sz="1100" b="0">
+                        <a:rPr sz="1050" b="0">
                           <a:solidFill>
                             <a:srgbClr val="1B2430"/>
                           </a:solidFill>
                           <a:latin typeface="Calibri"/>
                         </a:rPr>
-                        <a:t>list_projects, project_info, build_db, scaffold, generate, migrate, clean, diagram, docgen, toolchain_detect, questa_detect, questa_compile, questa_lint, model_status, build_model, run_model, run_cosim, regression, reg_access_plan, reg_access_test, check_job, list_jobs, read_log</a:t>
+                        <a:t>list_projects, project_info, build_db, scaffold, generate, migrate, clean, diagram, docgen, soc_manifest (P5), toolchain_detect, questa_detect, questa_compile, questa_lint, model_status, build_model, run_model, run_cosim, regression, reg_access_plan, reg_access_test, check_job, list_jobs, read_log</a:t>
                       </a:r>
                     </a:p>
                   </a:txBody>
@@ -22825,13 +23335,13 @@
                     <a:lstStyle/>
                     <a:p>
                       <a:r>
-                        <a:rPr sz="1100" b="1">
+                        <a:rPr sz="1050" b="1">
                           <a:solidFill>
                             <a:srgbClr val="1B2430"/>
                           </a:solidFill>
                           <a:latin typeface="Calibri"/>
                         </a:rPr>
-                        <a:t>lattice-cortex and the Radiant bundle</a:t>
+                        <a:t>lattice-cortex (160 tools; the ones the flow uses)</a:t>
                       </a:r>
                     </a:p>
                   </a:txBody>
@@ -22847,19 +23357,65 @@
                     <a:lstStyle/>
                     <a:p>
                       <a:r>
-                        <a:rPr sz="1100" b="0">
+                        <a:rPr sz="1050" b="0">
                           <a:solidFill>
                             <a:srgbClr val="1B2430"/>
                           </a:solidFill>
                           <a:latin typeface="Calibri"/>
                         </a:rPr>
-                        <a:t>IP facts and compatibility, Propel session and equivalence checks, DGE and SGE, firmware plan and tests; Radiant project and flow, timing closure levers, constraints lint, programming, Reveal (see their own references)</a:t>
+                        <a:t>lookup_ip, ip_search, ip_get_parameters, ip_get_ports, ip_get_memory_maps, ip_check_compatibility, find_protocol_bridge; parse_sbx, propel_session_new, propel_config_ip, propel_add_component, propel_connect_net, propel_assign_addr_seg, propel_session_validate, propel_execute; propel_replay_manifest and propel_compare_sbx_manifest (0.2.0); validate_topology, validate_build_schema (manifest-aware), validate_timing; decode_sge, firmware_plan, firmware_gen_tests, firmware_run_tests</a:t>
                       </a:r>
                     </a:p>
                   </a:txBody>
                   <a:tcPr marL="73152" marR="73152" marT="45720" marB="45720">
                     <a:solidFill>
                       <a:srgbClr val="FFFFFF"/>
+                    </a:solidFill>
+                  </a:tcPr>
+                </a:tc>
+              </a:tr>
+              <a:tr h="731520">
+                <a:tc>
+                  <a:txBody>
+                    <a:bodyPr/>
+                    <a:lstStyle/>
+                    <a:p>
+                      <a:r>
+                        <a:rPr sz="1050" b="1">
+                          <a:solidFill>
+                            <a:srgbClr val="1B2430"/>
+                          </a:solidFill>
+                          <a:latin typeface="Calibri"/>
+                        </a:rPr>
+                        <a:t>lattice-radiant-mcp (own installer)</a:t>
+                      </a:r>
+                    </a:p>
+                  </a:txBody>
+                  <a:tcPr marL="73152" marR="73152" marT="45720" marB="45720">
+                    <a:solidFill>
+                      <a:srgbClr val="EEF3F6"/>
+                    </a:solidFill>
+                  </a:tcPr>
+                </a:tc>
+                <a:tc>
+                  <a:txBody>
+                    <a:bodyPr/>
+                    <a:lstStyle/>
+                    <a:p>
+                      <a:r>
+                        <a:rPr sz="1050" b="0">
+                          <a:solidFill>
+                            <a:srgbClr val="1B2430"/>
+                          </a:solidFill>
+                          <a:latin typeface="Calibri"/>
+                        </a:rPr>
+                        <a:t>Radiant project and flow (prj_create, run_synthesis, run_map, run_par, run_export, run_timing), constraints lint, programming, Reveal tools; see its user guide</a:t>
+                      </a:r>
+                    </a:p>
+                  </a:txBody>
+                  <a:tcPr marL="73152" marR="73152" marT="45720" marB="45720">
+                    <a:solidFill>
+                      <a:srgbClr val="EEF3F6"/>
                     </a:solidFill>
                   </a:tcPr>
                 </a:tc>
@@ -23839,7 +24395,7 @@
             <a:avLst/>
           </a:prstGeom>
           <a:solidFill>
-            <a:srgbClr val="6C8EA4"/>
+            <a:srgbClr val="E0A458"/>
           </a:solidFill>
           <a:ln>
             <a:noFill/>
@@ -23942,7 +24498,7 @@
                 </a:solidFill>
                 <a:latin typeface="Calibri"/>
               </a:rPr>
-              <a:t>manifest generator and replay tool</a:t>
+              <a:t>tools done: soc_manifest, replay and compare (0.2.0); live replay after Gate 2</a:t>
             </a:r>
           </a:p>
         </p:txBody>
@@ -24144,7 +24700,7 @@
                 </a:solidFill>
                 <a:latin typeface="Calibri"/>
               </a:rPr>
-              <a:t>Open items for maintainers (recorded in the pilot's decisions): cortex-mcp README and skill refresh, P5 replay tools, the bundle's deferral note, the evaluation board's JTAG facts, the LSF gateway registration.</a:t>
+              <a:t>Open items for maintainers (recorded in the pilot's decisions): merge of the cortex-mcp flow_integration branch (pull request 150), cortex-mcp README and skill refresh, the evaluation board's JTAG facts, the LSF gateway registration, the Radiant server's timing-closure packages outside the bundle.</a:t>
             </a:r>
           </a:p>
         </p:txBody>
@@ -27836,7 +28392,7 @@
                 </a:solidFill>
                 <a:latin typeface="Cambria"/>
               </a:rPr>
-              <a:t>Five servers behind one agent, and who answers what</a:t>
+              <a:t>Four servers behind one agent, and who answers what</a:t>
             </a:r>
           </a:p>
         </p:txBody>
@@ -28162,7 +28718,7 @@
           <a:p>
             <a:pPr algn="l"/>
             <a:r>
-              <a:rPr sz="1150" b="0" i="0">
+              <a:rPr sz="1100" b="0" i="0">
                 <a:solidFill>
                   <a:srgbClr val="1B2430"/>
                 </a:solidFill>
@@ -28335,7 +28891,7 @@
           <a:p>
             <a:pPr algn="l"/>
             <a:r>
-              <a:rPr sz="1150" b="0" i="0">
+              <a:rPr sz="1100" b="0" i="0">
                 <a:solidFill>
                   <a:srgbClr val="1B2430"/>
                 </a:solidFill>
@@ -28508,13 +29064,13 @@
           <a:p>
             <a:pPr algn="l"/>
             <a:r>
-              <a:rPr sz="1150" b="0" i="0">
+              <a:rPr sz="1100" b="0" i="0">
                 <a:solidFill>
                   <a:srgbClr val="1B2430"/>
                 </a:solidFill>
                 <a:latin typeface="Calibri"/>
               </a:rPr>
-              <a:t>Propel IP facts and compatibility, the SoC session and its equivalence checks, DGE and SGE, firmware plan and tests.</a:t>
+              <a:t>Propel IP facts and compatibility, the SoC session and its equivalence checks, replay and comparison of the arch2code SoC manifest, DGE and SGE, firmware plan and tests.</a:t>
             </a:r>
           </a:p>
         </p:txBody>
@@ -28652,7 +29208,7 @@
                 </a:solidFill>
                 <a:latin typeface="Calibri"/>
               </a:rPr>
-              <a:t>lattice-radiant (bundle)</a:t>
+              <a:t>lattice-radiant-mcp</a:t>
             </a:r>
           </a:p>
         </p:txBody>
@@ -28681,20 +29237,185 @@
           <a:p>
             <a:pPr algn="l"/>
             <a:r>
-              <a:rPr sz="1150" b="0" i="0">
+              <a:rPr sz="1100" b="0" i="0">
                 <a:solidFill>
                   <a:srgbClr val="1B2430"/>
                 </a:solidFill>
                 <a:latin typeface="Calibri"/>
               </a:rPr>
-              <a:t>Radiant project, synthesis to bitstream, timing closure levers, constraints lint, programming, Reveal debug.</a:t>
+              <a:t>Radiant project, synthesis to bitstream, timing closure levers, constraints lint, programming, Reveal debug. Own installer, registered beside the bundle.</a:t>
+            </a:r>
+          </a:p>
+        </p:txBody>
+      </p:sp>
+      <p:sp>
+        <p:nvSpPr>
+          <p:cNvPr id="23" name="pill"/>
+          <p:cNvSpPr/>
+          <p:nvPr/>
+        </p:nvSpPr>
+        <p:spPr>
+          <a:xfrm>
+            <a:off x="3246120" y="1508760"/>
+            <a:ext cx="548640" cy="237744"/>
+          </a:xfrm>
+          <a:prstGeom prst="roundRect">
+            <a:avLst>
+              <a:gd name="adj" fmla="val 50000"/>
+            </a:avLst>
+          </a:prstGeom>
+          <a:solidFill>
+            <a:srgbClr val="9BD3C4"/>
+          </a:solidFill>
+          <a:ln>
+            <a:noFill/>
+          </a:ln>
+          <a:effectLst/>
+        </p:spPr>
+        <p:style>
+          <a:lnRef idx="1">
+            <a:schemeClr val="accent1"/>
+          </a:lnRef>
+          <a:fillRef idx="3">
+            <a:schemeClr val="accent1"/>
+          </a:fillRef>
+          <a:effectRef idx="2">
+            <a:schemeClr val="accent1"/>
+          </a:effectRef>
+          <a:fontRef idx="minor">
+            <a:schemeClr val="lt1"/>
+          </a:fontRef>
+        </p:style>
+        <p:txBody>
+          <a:bodyPr rtlCol="0" anchor="ctr" lIns="0" rIns="0" tIns="0" bIns="0" wrap="square"/>
+          <a:lstStyle/>
+          <a:p>
+            <a:pPr algn="ctr"/>
+            <a:r>
+              <a:rPr sz="850" b="1" i="0">
+                <a:solidFill>
+                  <a:srgbClr val="0F2A3F"/>
+                </a:solidFill>
+                <a:latin typeface="Calibri"/>
+              </a:rPr>
+              <a:t>bundle</a:t>
+            </a:r>
+          </a:p>
+        </p:txBody>
+      </p:sp>
+      <p:sp>
+        <p:nvSpPr>
+          <p:cNvPr id="24" name="pill"/>
+          <p:cNvSpPr/>
+          <p:nvPr/>
+        </p:nvSpPr>
+        <p:spPr>
+          <a:xfrm>
+            <a:off x="10927080" y="1508760"/>
+            <a:ext cx="548640" cy="237744"/>
+          </a:xfrm>
+          <a:prstGeom prst="roundRect">
+            <a:avLst>
+              <a:gd name="adj" fmla="val 50000"/>
+            </a:avLst>
+          </a:prstGeom>
+          <a:solidFill>
+            <a:srgbClr val="9BD3C4"/>
+          </a:solidFill>
+          <a:ln>
+            <a:noFill/>
+          </a:ln>
+          <a:effectLst/>
+        </p:spPr>
+        <p:style>
+          <a:lnRef idx="1">
+            <a:schemeClr val="accent1"/>
+          </a:lnRef>
+          <a:fillRef idx="3">
+            <a:schemeClr val="accent1"/>
+          </a:fillRef>
+          <a:effectRef idx="2">
+            <a:schemeClr val="accent1"/>
+          </a:effectRef>
+          <a:fontRef idx="minor">
+            <a:schemeClr val="lt1"/>
+          </a:fontRef>
+        </p:style>
+        <p:txBody>
+          <a:bodyPr rtlCol="0" anchor="ctr" lIns="0" rIns="0" tIns="0" bIns="0" wrap="square"/>
+          <a:lstStyle/>
+          <a:p>
+            <a:pPr algn="ctr"/>
+            <a:r>
+              <a:rPr sz="850" b="1" i="0">
+                <a:solidFill>
+                  <a:srgbClr val="0F2A3F"/>
+                </a:solidFill>
+                <a:latin typeface="Calibri"/>
+              </a:rPr>
+              <a:t>bundle</a:t>
+            </a:r>
+          </a:p>
+        </p:txBody>
+      </p:sp>
+      <p:sp>
+        <p:nvSpPr>
+          <p:cNvPr id="25" name="pill"/>
+          <p:cNvSpPr/>
+          <p:nvPr/>
+        </p:nvSpPr>
+        <p:spPr>
+          <a:xfrm>
+            <a:off x="3246120" y="4480560"/>
+            <a:ext cx="548640" cy="237744"/>
+          </a:xfrm>
+          <a:prstGeom prst="roundRect">
+            <a:avLst>
+              <a:gd name="adj" fmla="val 50000"/>
+            </a:avLst>
+          </a:prstGeom>
+          <a:solidFill>
+            <a:srgbClr val="9BD3C4"/>
+          </a:solidFill>
+          <a:ln>
+            <a:noFill/>
+          </a:ln>
+          <a:effectLst/>
+        </p:spPr>
+        <p:style>
+          <a:lnRef idx="1">
+            <a:schemeClr val="accent1"/>
+          </a:lnRef>
+          <a:fillRef idx="3">
+            <a:schemeClr val="accent1"/>
+          </a:fillRef>
+          <a:effectRef idx="2">
+            <a:schemeClr val="accent1"/>
+          </a:effectRef>
+          <a:fontRef idx="minor">
+            <a:schemeClr val="lt1"/>
+          </a:fontRef>
+        </p:style>
+        <p:txBody>
+          <a:bodyPr rtlCol="0" anchor="ctr" lIns="0" rIns="0" tIns="0" bIns="0" wrap="square"/>
+          <a:lstStyle/>
+          <a:p>
+            <a:pPr algn="ctr"/>
+            <a:r>
+              <a:rPr sz="850" b="1" i="0">
+                <a:solidFill>
+                  <a:srgbClr val="0F2A3F"/>
+                </a:solidFill>
+                <a:latin typeface="Calibri"/>
+              </a:rPr>
+              <a:t>bundle</a:t>
             </a:r>
           </a:p>
         </p:txBody>
       </p:sp>
       <p:cxnSp>
         <p:nvCxnSpPr>
-          <p:cNvPr id="23" name="Connector 22"/>
+          <p:cNvPr id="26" name="Connector 25"/>
           <p:cNvCxnSpPr/>
           <p:nvPr/>
         </p:nvCxnSpPr>
@@ -28730,7 +29451,7 @@
       </p:cxnSp>
       <p:cxnSp>
         <p:nvCxnSpPr>
-          <p:cNvPr id="24" name="Connector 23"/>
+          <p:cNvPr id="27" name="Connector 26"/>
           <p:cNvCxnSpPr/>
           <p:nvPr/>
         </p:nvCxnSpPr>
@@ -28766,7 +29487,7 @@
       </p:cxnSp>
       <p:cxnSp>
         <p:nvCxnSpPr>
-          <p:cNvPr id="25" name="Connector 24"/>
+          <p:cNvPr id="28" name="Connector 27"/>
           <p:cNvCxnSpPr/>
           <p:nvPr/>
         </p:nvCxnSpPr>
@@ -28802,7 +29523,7 @@
       </p:cxnSp>
       <p:cxnSp>
         <p:nvCxnSpPr>
-          <p:cNvPr id="26" name="Connector 25"/>
+          <p:cNvPr id="29" name="Connector 28"/>
           <p:cNvCxnSpPr/>
           <p:nvPr/>
         </p:nvCxnSpPr>
@@ -28838,7 +29559,7 @@
       </p:cxnSp>
       <p:sp>
         <p:nvSpPr>
-          <p:cNvPr id="27" name="card"/>
+          <p:cNvPr id="30" name="card"/>
           <p:cNvSpPr/>
           <p:nvPr/>
         </p:nvSpPr>
@@ -28888,7 +29609,7 @@
       </p:sp>
       <p:sp>
         <p:nvSpPr>
-          <p:cNvPr id="28" name="TextBox 27"/>
+          <p:cNvPr id="31" name="TextBox 30"/>
           <p:cNvSpPr txBox="1"/>
           <p:nvPr/>
         </p:nvSpPr>
@@ -28916,7 +29637,7 @@
                 </a:solidFill>
                 <a:latin typeface="Calibri"/>
               </a:rPr>
-              <a:t>Precedence: a fact is taken from the server that owns it (IP facts from lattice-cortex, device facts from the Radiant bundle, verified designs from cortex-kb, the project's own YAML from arch2code); a conflict is recorded, never averaged.</a:t>
+              <a:t>Precedence: a fact is taken from the server that owns it (IP facts from lattice-cortex, device facts from the Radiant server, verified designs from cortex-kb, the project's own YAML from arch2code); a conflict is recorded, never averaged.</a:t>
             </a:r>
           </a:p>
         </p:txBody>

</xml_diff>